<commit_message>
Finalize figure pipeline, dropped table 1 and added figure 6.
</commit_message>
<xml_diff>
--- a/figure_pipeline/fig2_cv_comparison/fig2_panels/fig2_panelD.pptx
+++ b/figure_pipeline/fig2_cv_comparison/fig2_panels/fig2_panelD.pptx
@@ -208,7 +208,7 @@
           <a:p>
             <a:fld id="{23533F18-0B0B-4B4C-81C3-BEB9DEEB96D4}" type="datetimeFigureOut">
               <a:rPr lang="en-US" smtClean="0"/>
-              <a:t>4/15/2026</a:t>
+              <a:t>4/19/2026</a:t>
             </a:fld>
             <a:endParaRPr lang="en-US"/>
           </a:p>
@@ -716,7 +716,7 @@
           <a:p>
             <a:fld id="{59B8D3E2-249C-484A-821A-68E36AE56069}" type="datetimeFigureOut">
               <a:rPr lang="en-US" smtClean="0"/>
-              <a:t>4/15/2026</a:t>
+              <a:t>4/19/2026</a:t>
             </a:fld>
             <a:endParaRPr lang="en-US"/>
           </a:p>
@@ -914,7 +914,7 @@
           <a:p>
             <a:fld id="{59B8D3E2-249C-484A-821A-68E36AE56069}" type="datetimeFigureOut">
               <a:rPr lang="en-US" smtClean="0"/>
-              <a:t>4/15/2026</a:t>
+              <a:t>4/19/2026</a:t>
             </a:fld>
             <a:endParaRPr lang="en-US"/>
           </a:p>
@@ -1122,7 +1122,7 @@
           <a:p>
             <a:fld id="{59B8D3E2-249C-484A-821A-68E36AE56069}" type="datetimeFigureOut">
               <a:rPr lang="en-US" smtClean="0"/>
-              <a:t>4/15/2026</a:t>
+              <a:t>4/19/2026</a:t>
             </a:fld>
             <a:endParaRPr lang="en-US"/>
           </a:p>
@@ -1320,7 +1320,7 @@
           <a:p>
             <a:fld id="{59B8D3E2-249C-484A-821A-68E36AE56069}" type="datetimeFigureOut">
               <a:rPr lang="en-US" smtClean="0"/>
-              <a:t>4/15/2026</a:t>
+              <a:t>4/19/2026</a:t>
             </a:fld>
             <a:endParaRPr lang="en-US"/>
           </a:p>
@@ -1595,7 +1595,7 @@
           <a:p>
             <a:fld id="{59B8D3E2-249C-484A-821A-68E36AE56069}" type="datetimeFigureOut">
               <a:rPr lang="en-US" smtClean="0"/>
-              <a:t>4/15/2026</a:t>
+              <a:t>4/19/2026</a:t>
             </a:fld>
             <a:endParaRPr lang="en-US"/>
           </a:p>
@@ -1860,7 +1860,7 @@
           <a:p>
             <a:fld id="{59B8D3E2-249C-484A-821A-68E36AE56069}" type="datetimeFigureOut">
               <a:rPr lang="en-US" smtClean="0"/>
-              <a:t>4/15/2026</a:t>
+              <a:t>4/19/2026</a:t>
             </a:fld>
             <a:endParaRPr lang="en-US"/>
           </a:p>
@@ -2272,7 +2272,7 @@
           <a:p>
             <a:fld id="{59B8D3E2-249C-484A-821A-68E36AE56069}" type="datetimeFigureOut">
               <a:rPr lang="en-US" smtClean="0"/>
-              <a:t>4/15/2026</a:t>
+              <a:t>4/19/2026</a:t>
             </a:fld>
             <a:endParaRPr lang="en-US"/>
           </a:p>
@@ -2413,7 +2413,7 @@
           <a:p>
             <a:fld id="{59B8D3E2-249C-484A-821A-68E36AE56069}" type="datetimeFigureOut">
               <a:rPr lang="en-US" smtClean="0"/>
-              <a:t>4/15/2026</a:t>
+              <a:t>4/19/2026</a:t>
             </a:fld>
             <a:endParaRPr lang="en-US"/>
           </a:p>
@@ -2526,7 +2526,7 @@
           <a:p>
             <a:fld id="{59B8D3E2-249C-484A-821A-68E36AE56069}" type="datetimeFigureOut">
               <a:rPr lang="en-US" smtClean="0"/>
-              <a:t>4/15/2026</a:t>
+              <a:t>4/19/2026</a:t>
             </a:fld>
             <a:endParaRPr lang="en-US"/>
           </a:p>
@@ -2837,7 +2837,7 @@
           <a:p>
             <a:fld id="{59B8D3E2-249C-484A-821A-68E36AE56069}" type="datetimeFigureOut">
               <a:rPr lang="en-US" smtClean="0"/>
-              <a:t>4/15/2026</a:t>
+              <a:t>4/19/2026</a:t>
             </a:fld>
             <a:endParaRPr lang="en-US"/>
           </a:p>
@@ -3125,7 +3125,7 @@
           <a:p>
             <a:fld id="{59B8D3E2-249C-484A-821A-68E36AE56069}" type="datetimeFigureOut">
               <a:rPr lang="en-US" smtClean="0"/>
-              <a:t>4/15/2026</a:t>
+              <a:t>4/19/2026</a:t>
             </a:fld>
             <a:endParaRPr lang="en-US"/>
           </a:p>
@@ -3366,7 +3366,7 @@
           <a:p>
             <a:fld id="{59B8D3E2-249C-484A-821A-68E36AE56069}" type="datetimeFigureOut">
               <a:rPr lang="en-US" smtClean="0"/>
-              <a:t>4/15/2026</a:t>
+              <a:t>4/19/2026</a:t>
             </a:fld>
             <a:endParaRPr lang="en-US"/>
           </a:p>
@@ -4016,7 +4016,7 @@
             </a:r>
             <a:r>
               <a:rPr lang="en-US" sz="1200" dirty="0"/>
-              <a:t>(can be either CV1 or CV2):</a:t>
+              <a:t>(can be either of these):</a:t>
             </a:r>
           </a:p>
           <a:p>
@@ -4025,7 +4025,7 @@
           <a:p>
             <a:r>
               <a:rPr lang="en-US" sz="1200" b="1" dirty="0"/>
-              <a:t>CV1 (Pair-Held-Out):</a:t>
+              <a:t>Drug-Pair-Held-Out:</a:t>
             </a:r>
           </a:p>
           <a:p>
@@ -4062,7 +4062,7 @@
           <a:p>
             <a:r>
               <a:rPr lang="en-US" sz="1200" b="1" dirty="0"/>
-              <a:t>CV2 (Pair + Strain-Held-Out):</a:t>
+              <a:t>Drug-Pair-Strain-Held-Out:</a:t>
             </a:r>
           </a:p>
           <a:p>

</xml_diff>